<commit_message>
Regenerate Chinese PPT from scratch with python-pptx
- Regenerated using gen_ppt.py (was corrupted by ZIP manipulation)
- 25 slides, 72KB, clean structure
- No school references
</commit_message>
<xml_diff>
--- a/AMA-终汇报-PPT-中文.pptx
+++ b/AMA-终汇报-PPT-中文.pptx
@@ -3102,8 +3102,290 @@
 </p:sldMaster>
 </file>
 
-<file path=ppt/slides/slide1.xml><?xml version='1.0' encoding='UTF-8' standalone='yes'?>
-<p:sld xmlns:a="http://schemas.openxmlformats.org/drawingml/2006/main" xmlns:p="http://schemas.openxmlformats.org/presentationml/2006/main" xmlns:r="http://schemas.openxmlformats.org/officeDocument/2006/relationships"><p:cSld><p:bg><p:bgPr><a:solidFill><a:srgbClr val="002050"/></a:solidFill><a:effectLst/></p:bgPr></p:bg><p:spTree><p:nvGrpSpPr><p:cNvPr id="1" name=""/><p:cNvGrpSpPr/><p:nvPr/></p:nvGrpSpPr><p:grpSpPr/><p:sp><p:nvSpPr><p:cNvPr id="2" name="Rectangle 1"/><p:cNvSpPr/><p:nvPr/></p:nvSpPr><p:spPr><a:xfrm><a:off x="0" y="0"/><a:ext cx="12191695" cy="73152"/></a:xfrm><a:prstGeom prst="rect"><a:avLst/></a:prstGeom><a:solidFill><a:srgbClr val="FFD700"/></a:solidFill><a:ln><a:noFill/></a:ln></p:spPr><p:style><a:lnRef idx="1"><a:schemeClr val="accent1"/></a:lnRef><a:fillRef idx="3"><a:schemeClr val="accent1"/></a:fillRef><a:effectRef idx="2"><a:schemeClr val="accent1"/></a:effectRef><a:fontRef idx="minor"><a:schemeClr val="lt1"/></a:fontRef></p:style><p:txBody><a:bodyPr rtlCol="0" anchor="ctr"/><a:lstStyle/><a:p><a:pPr algn="ctr"/></a:p></p:txBody></p:sp><p:sp><p:nvSpPr><p:cNvPr id="3" name="TextBox 2"/><p:cNvSpPr txBox="1"/><p:nvPr/></p:nvSpPr><p:spPr><a:xfrm><a:off x="914400" y="1645920"/><a:ext cx="10332720" cy="1097280"/></a:xfrm><a:prstGeom prst="rect"><a:avLst/></a:prstGeom><a:noFill/></p:spPr><p:txBody><a:bodyPr wrap="square"><a:spAutoFit/></a:bodyPr><a:lstStyle/><a:p><a:pPr algn="ctr"><a:defRPr sz="4200" b="1"><a:solidFill><a:srgbClr val="FFFFFF"/></a:solidFill><a:latin typeface="Microsoft YaHei"/></a:defRPr></a:pPr><a:r><a:t>Autonomous Retail Intelligence</a:t></a:r><a:br/><a:r><a:t>Agent Platform</a:t></a:r></a:p></p:txBody></p:sp><p:sp><p:nvSpPr><p:cNvPr id="4" name="TextBox 3"/><p:cNvSpPr txBox="1"/><p:nvPr/></p:nvSpPr><p:spPr><a:xfrm><a:off x="914400" y="3017520"/><a:ext cx="10332720" cy="731520"/></a:xfrm><a:prstGeom prst="rect"><a:avLst/></a:prstGeom><a:noFill/></p:spPr><p:txBody><a:bodyPr wrap="square"><a:spAutoFit/></a:bodyPr><a:lstStyle/><a:p><a:pPr algn="ctr"><a:defRPr sz="2400" b="0"><a:solidFill><a:srgbClr val="FFD700"/></a:solidFill><a:latin typeface="Microsoft YaHei"/></a:defRPr></a:pPr><a:r><a:t>基于优衣库的多 Agent 智能零售平台</a:t></a:r></a:p></p:txBody></p:sp><p:sp><p:nvSpPr><p:cNvPr id="5" name="Rectangle 4"/><p:cNvSpPr/><p:nvPr/></p:nvSpPr><p:spPr><a:xfrm><a:off x="4572000" y="3931920"/><a:ext cx="3017520" cy="36576"/></a:xfrm><a:prstGeom prst="rect"><a:avLst/></a:prstGeom><a:solidFill><a:srgbClr val="FFD700"/></a:solidFill><a:ln><a:noFill/></a:ln></p:spPr><p:style><a:lnRef idx="1"><a:schemeClr val="accent1"/></a:lnRef><a:fillRef idx="3"><a:schemeClr val="accent1"/></a:fillRef><a:effectRef idx="2"><a:schemeClr val="accent1"/></a:effectRef><a:fontRef idx="minor"><a:schemeClr val="lt1"/></a:fontRef></p:style><p:txBody><a:bodyPr rtlCol="0" anchor="ctr"/><a:lstStyle/><a:p><a:pPr algn="ctr"/></a:p></p:txBody></p:sp><p:sp><p:nvSpPr><p:cNvPr id="6" name="TextBox 5"/><p:cNvSpPr txBox="1"/><p:nvPr/></p:nvSpPr><p:spPr><a:xfrm><a:off x="914400" y="4389120"/><a:ext cx="10332720" cy="1371600"/></a:xfrm><a:prstGeom prst="rect"><a:avLst/></a:prstGeom><a:noFill/></p:spPr><p:txBody><a:bodyPr wrap="square"><a:spAutoFit/></a:bodyPr><a:lstStyle/><a:p><a:pPr algn="ctr"><a:spcAft><a:spcPts val="720"/></a:spcAft><a:defRPr sz="1800" b="0"><a:solidFill><a:srgbClr val="CCCCCC"/></a:solidFill><a:latin typeface="Microsoft YaHei"/></a:defRPr></a:pPr><a:r><a:t>汇报人：圆子  Senior Solution Engineer, Azure & AI Platform</a:t></a:r></a:p><a:p><a:pPr algn="ctr"><a:spcAft><a:spcPts val="720"/></a:spcAft><a:defRPr sz="1800" b="0"><a:solidFill><a:srgbClr val="CCCCCC"/></a:solidFill><a:latin typeface="Microsoft YaHei"/></a:defRPr></a:pPr><a:r><a:t>AMA Capstone Project  |  Project 46</a:t></a:r></a:p></p:txBody></p:sp><p:sp><p:nvSpPr><p:cNvPr id="7" name="Rectangle 6"/><p:cNvSpPr/><p:nvPr/></p:nvSpPr><p:spPr><a:xfrm><a:off x="0" y="6784848"/><a:ext cx="12191695" cy="73152"/></a:xfrm><a:prstGeom prst="rect"><a:avLst/></a:prstGeom><a:solidFill><a:srgbClr val="FFD700"/></a:solidFill><a:ln><a:noFill/></a:ln></p:spPr><p:style><a:lnRef idx="1"><a:schemeClr val="accent1"/></a:lnRef><a:fillRef idx="3"><a:schemeClr val="accent1"/></a:fillRef><a:effectRef idx="2"><a:schemeClr val="accent1"/></a:effectRef><a:fontRef idx="minor"><a:schemeClr val="lt1"/></a:fontRef></p:style><p:txBody><a:bodyPr rtlCol="0" anchor="ctr"/><a:lstStyle/><a:p><a:pPr algn="ctr"/></a:p></p:txBody></p:sp></p:spTree></p:cSld><p:clrMapOvr><a:masterClrMapping/></p:clrMapOvr></p:sld>
+<file path=ppt/slides/slide1.xml><?xml version="1.0" encoding="utf-8"?>
+<p:sld xmlns:a="http://schemas.openxmlformats.org/drawingml/2006/main" xmlns:p="http://schemas.openxmlformats.org/presentationml/2006/main" xmlns:r="http://schemas.openxmlformats.org/officeDocument/2006/relationships">
+  <p:cSld>
+    <p:bg>
+      <p:bgPr>
+        <a:solidFill>
+          <a:srgbClr val="002050"/>
+        </a:solidFill>
+        <a:effectLst/>
+      </p:bgPr>
+    </p:bg>
+    <p:spTree>
+      <p:nvGrpSpPr>
+        <p:cNvPr id="1" name=""/>
+        <p:cNvGrpSpPr/>
+        <p:nvPr/>
+      </p:nvGrpSpPr>
+      <p:grpSpPr/>
+      <p:sp>
+        <p:nvSpPr>
+          <p:cNvPr id="2" name="Rectangle 1"/>
+          <p:cNvSpPr/>
+          <p:nvPr/>
+        </p:nvSpPr>
+        <p:spPr>
+          <a:xfrm>
+            <a:off x="0" y="0"/>
+            <a:ext cx="12191695" cy="73152"/>
+          </a:xfrm>
+          <a:prstGeom prst="rect">
+            <a:avLst/>
+          </a:prstGeom>
+          <a:solidFill>
+            <a:srgbClr val="FFD700"/>
+          </a:solidFill>
+          <a:ln>
+            <a:noFill/>
+          </a:ln>
+        </p:spPr>
+        <p:style>
+          <a:lnRef idx="1">
+            <a:schemeClr val="accent1"/>
+          </a:lnRef>
+          <a:fillRef idx="3">
+            <a:schemeClr val="accent1"/>
+          </a:fillRef>
+          <a:effectRef idx="2">
+            <a:schemeClr val="accent1"/>
+          </a:effectRef>
+          <a:fontRef idx="minor">
+            <a:schemeClr val="lt1"/>
+          </a:fontRef>
+        </p:style>
+        <p:txBody>
+          <a:bodyPr rtlCol="0" anchor="ctr"/>
+          <a:lstStyle/>
+          <a:p>
+            <a:pPr algn="ctr"/>
+          </a:p>
+        </p:txBody>
+      </p:sp>
+      <p:sp>
+        <p:nvSpPr>
+          <p:cNvPr id="3" name="TextBox 2"/>
+          <p:cNvSpPr txBox="1"/>
+          <p:nvPr/>
+        </p:nvSpPr>
+        <p:spPr>
+          <a:xfrm>
+            <a:off x="914400" y="1645920"/>
+            <a:ext cx="10332720" cy="1097280"/>
+          </a:xfrm>
+          <a:prstGeom prst="rect">
+            <a:avLst/>
+          </a:prstGeom>
+          <a:noFill/>
+        </p:spPr>
+        <p:txBody>
+          <a:bodyPr wrap="square">
+            <a:spAutoFit/>
+          </a:bodyPr>
+          <a:lstStyle/>
+          <a:p>
+            <a:pPr algn="ctr">
+              <a:defRPr sz="4200" b="1">
+                <a:solidFill>
+                  <a:srgbClr val="FFFFFF"/>
+                </a:solidFill>
+                <a:latin typeface="Microsoft YaHei"/>
+              </a:defRPr>
+            </a:pPr>
+            <a:r>
+              <a:t>Autonomous Retail Intelligence</a:t>
+            </a:r>
+            <a:br/>
+            <a:r>
+              <a:t>Agent Platform</a:t>
+            </a:r>
+          </a:p>
+        </p:txBody>
+      </p:sp>
+      <p:sp>
+        <p:nvSpPr>
+          <p:cNvPr id="4" name="TextBox 3"/>
+          <p:cNvSpPr txBox="1"/>
+          <p:nvPr/>
+        </p:nvSpPr>
+        <p:spPr>
+          <a:xfrm>
+            <a:off x="914400" y="3017520"/>
+            <a:ext cx="10332720" cy="731520"/>
+          </a:xfrm>
+          <a:prstGeom prst="rect">
+            <a:avLst/>
+          </a:prstGeom>
+          <a:noFill/>
+        </p:spPr>
+        <p:txBody>
+          <a:bodyPr wrap="square">
+            <a:spAutoFit/>
+          </a:bodyPr>
+          <a:lstStyle/>
+          <a:p>
+            <a:pPr algn="ctr">
+              <a:defRPr sz="2400" b="0">
+                <a:solidFill>
+                  <a:srgbClr val="FFD700"/>
+                </a:solidFill>
+                <a:latin typeface="Microsoft YaHei"/>
+              </a:defRPr>
+            </a:pPr>
+            <a:r>
+              <a:t>基于优衣库的多 Agent 智能零售平台</a:t>
+            </a:r>
+          </a:p>
+        </p:txBody>
+      </p:sp>
+      <p:sp>
+        <p:nvSpPr>
+          <p:cNvPr id="5" name="Rectangle 4"/>
+          <p:cNvSpPr/>
+          <p:nvPr/>
+        </p:nvSpPr>
+        <p:spPr>
+          <a:xfrm>
+            <a:off x="4572000" y="3931920"/>
+            <a:ext cx="3017520" cy="36576"/>
+          </a:xfrm>
+          <a:prstGeom prst="rect">
+            <a:avLst/>
+          </a:prstGeom>
+          <a:solidFill>
+            <a:srgbClr val="FFD700"/>
+          </a:solidFill>
+          <a:ln>
+            <a:noFill/>
+          </a:ln>
+        </p:spPr>
+        <p:style>
+          <a:lnRef idx="1">
+            <a:schemeClr val="accent1"/>
+          </a:lnRef>
+          <a:fillRef idx="3">
+            <a:schemeClr val="accent1"/>
+          </a:fillRef>
+          <a:effectRef idx="2">
+            <a:schemeClr val="accent1"/>
+          </a:effectRef>
+          <a:fontRef idx="minor">
+            <a:schemeClr val="lt1"/>
+          </a:fontRef>
+        </p:style>
+        <p:txBody>
+          <a:bodyPr rtlCol="0" anchor="ctr"/>
+          <a:lstStyle/>
+          <a:p>
+            <a:pPr algn="ctr"/>
+          </a:p>
+        </p:txBody>
+      </p:sp>
+      <p:sp>
+        <p:nvSpPr>
+          <p:cNvPr id="6" name="TextBox 5"/>
+          <p:cNvSpPr txBox="1"/>
+          <p:nvPr/>
+        </p:nvSpPr>
+        <p:spPr>
+          <a:xfrm>
+            <a:off x="914400" y="4389120"/>
+            <a:ext cx="10332720" cy="1371600"/>
+          </a:xfrm>
+          <a:prstGeom prst="rect">
+            <a:avLst/>
+          </a:prstGeom>
+          <a:noFill/>
+        </p:spPr>
+        <p:txBody>
+          <a:bodyPr wrap="square">
+            <a:spAutoFit/>
+          </a:bodyPr>
+          <a:lstStyle/>
+          <a:p>
+            <a:pPr algn="ctr">
+              <a:spcAft>
+                <a:spcPts val="720"/>
+              </a:spcAft>
+              <a:defRPr sz="1800" b="0">
+                <a:solidFill>
+                  <a:srgbClr val="CCCCCC"/>
+                </a:solidFill>
+                <a:latin typeface="Microsoft YaHei"/>
+              </a:defRPr>
+            </a:pPr>
+            <a:r>
+              <a:t>汇报人：圆子  |  Senior Solution Engineer</a:t>
+            </a:r>
+          </a:p>
+          <a:p>
+            <a:pPr algn="ctr">
+              <a:spcAft>
+                <a:spcPts val="720"/>
+              </a:spcAft>
+              <a:defRPr sz="1800" b="0">
+                <a:solidFill>
+                  <a:srgbClr val="CCCCCC"/>
+                </a:solidFill>
+                <a:latin typeface="Microsoft YaHei"/>
+              </a:defRPr>
+            </a:pPr>
+            <a:r>
+              <a:t>AMA Capstone Project  |  Project 46</a:t>
+            </a:r>
+          </a:p>
+        </p:txBody>
+      </p:sp>
+      <p:sp>
+        <p:nvSpPr>
+          <p:cNvPr id="7" name="Rectangle 6"/>
+          <p:cNvSpPr/>
+          <p:nvPr/>
+        </p:nvSpPr>
+        <p:spPr>
+          <a:xfrm>
+            <a:off x="0" y="6784848"/>
+            <a:ext cx="12191695" cy="73152"/>
+          </a:xfrm>
+          <a:prstGeom prst="rect">
+            <a:avLst/>
+          </a:prstGeom>
+          <a:solidFill>
+            <a:srgbClr val="FFD700"/>
+          </a:solidFill>
+          <a:ln>
+            <a:noFill/>
+          </a:ln>
+        </p:spPr>
+        <p:style>
+          <a:lnRef idx="1">
+            <a:schemeClr val="accent1"/>
+          </a:lnRef>
+          <a:fillRef idx="3">
+            <a:schemeClr val="accent1"/>
+          </a:fillRef>
+          <a:effectRef idx="2">
+            <a:schemeClr val="accent1"/>
+          </a:effectRef>
+          <a:fontRef idx="minor">
+            <a:schemeClr val="lt1"/>
+          </a:fontRef>
+        </p:style>
+        <p:txBody>
+          <a:bodyPr rtlCol="0" anchor="ctr"/>
+          <a:lstStyle/>
+          <a:p>
+            <a:pPr algn="ctr"/>
+          </a:p>
+        </p:txBody>
+      </p:sp>
+    </p:spTree>
+  </p:cSld>
+  <p:clrMapOvr>
+    <a:masterClrMapping/>
+  </p:clrMapOvr>
+</p:sld>
 </file>
 
 <file path=ppt/slides/slide10.xml><?xml version="1.0" encoding="utf-8"?>
@@ -14167,8 +14449,315 @@
 </p:sld>
 </file>
 
-<file path=ppt/slides/slide25.xml><?xml version='1.0' encoding='UTF-8' standalone='yes'?>
-<p:sld xmlns:a="http://schemas.openxmlformats.org/drawingml/2006/main" xmlns:p="http://schemas.openxmlformats.org/presentationml/2006/main" xmlns:r="http://schemas.openxmlformats.org/officeDocument/2006/relationships"><p:cSld><p:bg><p:bgPr><a:solidFill><a:srgbClr val="002050"/></a:solidFill><a:effectLst/></p:bgPr></p:bg><p:spTree><p:nvGrpSpPr><p:cNvPr id="1" name=""/><p:cNvGrpSpPr/><p:nvPr/></p:nvGrpSpPr><p:grpSpPr/><p:sp><p:nvSpPr><p:cNvPr id="2" name="Rectangle 1"/><p:cNvSpPr/><p:nvPr/></p:nvSpPr><p:spPr><a:xfrm><a:off x="0" y="0"/><a:ext cx="12191695" cy="73152"/></a:xfrm><a:prstGeom prst="rect"><a:avLst/></a:prstGeom><a:solidFill><a:srgbClr val="FFD700"/></a:solidFill><a:ln><a:noFill/></a:ln></p:spPr><p:style><a:lnRef idx="1"><a:schemeClr val="accent1"/></a:lnRef><a:fillRef idx="3"><a:schemeClr val="accent1"/></a:fillRef><a:effectRef idx="2"><a:schemeClr val="accent1"/></a:effectRef><a:fontRef idx="minor"><a:schemeClr val="lt1"/></a:fontRef></p:style><p:txBody><a:bodyPr rtlCol="0" anchor="ctr"/><a:lstStyle/><a:p><a:pPr algn="ctr"/></a:p></p:txBody></p:sp><p:sp><p:nvSpPr><p:cNvPr id="3" name="TextBox 2"/><p:cNvSpPr txBox="1"/><p:nvPr/></p:nvSpPr><p:spPr><a:xfrm><a:off x="914400" y="1828800"/><a:ext cx="10332720" cy="1371600"/></a:xfrm><a:prstGeom prst="rect"><a:avLst/></a:prstGeom><a:noFill/></p:spPr><p:txBody><a:bodyPr wrap="square"><a:spAutoFit/></a:bodyPr><a:lstStyle/><a:p><a:pPr algn="ctr"><a:defRPr sz="5200" b="1"><a:solidFill><a:srgbClr val="FFFFFF"/></a:solidFill><a:latin typeface="Microsoft YaHei"/></a:defRPr></a:pPr><a:r><a:t>Thank You</a:t></a:r></a:p></p:txBody></p:sp><p:sp><p:nvSpPr><p:cNvPr id="4" name="TextBox 3"/><p:cNvSpPr txBox="1"/><p:nvPr/></p:nvSpPr><p:spPr><a:xfrm><a:off x="914400" y="3200400"/><a:ext cx="10332720" cy="731520"/></a:xfrm><a:prstGeom prst="rect"><a:avLst/></a:prstGeom><a:noFill/></p:spPr><p:txBody><a:bodyPr wrap="square"><a:spAutoFit/></a:bodyPr><a:lstStyle/><a:p><a:pPr algn="ctr"><a:defRPr sz="3200" b="0"><a:solidFill><a:srgbClr val="FFD700"/></a:solidFill><a:latin typeface="Microsoft YaHei"/></a:defRPr></a:pPr><a:r><a:t>谢谢</a:t></a:r></a:p></p:txBody></p:sp><p:sp><p:nvSpPr><p:cNvPr id="5" name="Rectangle 4"/><p:cNvSpPr/><p:nvPr/></p:nvSpPr><p:spPr><a:xfrm><a:off x="4572000" y="4114800"/><a:ext cx="3017520" cy="36576"/></a:xfrm><a:prstGeom prst="rect"><a:avLst/></a:prstGeom><a:solidFill><a:srgbClr val="FFD700"/></a:solidFill><a:ln><a:noFill/></a:ln></p:spPr><p:style><a:lnRef idx="1"><a:schemeClr val="accent1"/></a:lnRef><a:fillRef idx="3"><a:schemeClr val="accent1"/></a:fillRef><a:effectRef idx="2"><a:schemeClr val="accent1"/></a:effectRef><a:fontRef idx="minor"><a:schemeClr val="lt1"/></a:fontRef></p:style><p:txBody><a:bodyPr rtlCol="0" anchor="ctr"/><a:lstStyle/><a:p><a:pPr algn="ctr"/></a:p></p:txBody></p:sp><p:sp><p:nvSpPr><p:cNvPr id="6" name="TextBox 5"/><p:cNvSpPr txBox="1"/><p:nvPr/></p:nvSpPr><p:spPr><a:xfrm><a:off x="914400" y="4572000"/><a:ext cx="10332720" cy="1371600"/></a:xfrm><a:prstGeom prst="rect"><a:avLst/></a:prstGeom><a:noFill/></p:spPr><p:txBody><a:bodyPr wrap="square"><a:spAutoFit/></a:bodyPr><a:lstStyle/><a:p><a:pPr algn="ctr"><a:spcAft><a:spcPts val="720"/></a:spcAft><a:defRPr sz="1800" b="0"><a:solidFill><a:srgbClr val="CCCCCC"/></a:solidFill><a:latin typeface="Microsoft YaHei"/></a:defRPr></a:pPr><a:r><a:t>Q &amp; A</a:t></a:r></a:p><a:p><a:pPr algn="ctr"><a:spcAft><a:spcPts val="720"/></a:spcAft><a:defRPr sz="1800" b="0"><a:solidFill><a:srgbClr val="CCCCCC"/></a:solidFill><a:latin typeface="Microsoft YaHei"/></a:defRPr></a:pPr></a:p><a:p><a:pPr algn="ctr"><a:spcAft><a:spcPts val="720"/></a:spcAft><a:defRPr sz="1800" b="0"><a:solidFill><a:srgbClr val="CCCCCC"/></a:solidFill><a:latin typeface="Microsoft YaHei"/></a:defRPr></a:pPr><a:r><a:t>汇报人：圆子  Senior Solution Engineer, Azure & AI Platform</a:t></a:r></a:p><a:p><a:pPr algn="ctr"><a:spcAft><a:spcPts val="720"/></a:spcAft><a:defRPr sz="1800" b="0"><a:solidFill><a:srgbClr val="CCCCCC"/></a:solidFill><a:latin typeface="Microsoft YaHei"/></a:defRPr></a:pPr><a:r><a:t>Project 46 — Autonomous Retail Intelligence Agent Platform</a:t></a:r></a:p></p:txBody></p:sp><p:sp><p:nvSpPr><p:cNvPr id="7" name="Rectangle 6"/><p:cNvSpPr/><p:nvPr/></p:nvSpPr><p:spPr><a:xfrm><a:off x="0" y="6784848"/><a:ext cx="12191695" cy="73152"/></a:xfrm><a:prstGeom prst="rect"><a:avLst/></a:prstGeom><a:solidFill><a:srgbClr val="FFD700"/></a:solidFill><a:ln><a:noFill/></a:ln></p:spPr><p:style><a:lnRef idx="1"><a:schemeClr val="accent1"/></a:lnRef><a:fillRef idx="3"><a:schemeClr val="accent1"/></a:fillRef><a:effectRef idx="2"><a:schemeClr val="accent1"/></a:effectRef><a:fontRef idx="minor"><a:schemeClr val="lt1"/></a:fontRef></p:style><p:txBody><a:bodyPr rtlCol="0" anchor="ctr"/><a:lstStyle/><a:p><a:pPr algn="ctr"/></a:p></p:txBody></p:sp></p:spTree></p:cSld><p:clrMapOvr><a:masterClrMapping/></p:clrMapOvr></p:sld>
+<file path=ppt/slides/slide25.xml><?xml version="1.0" encoding="utf-8"?>
+<p:sld xmlns:a="http://schemas.openxmlformats.org/drawingml/2006/main" xmlns:p="http://schemas.openxmlformats.org/presentationml/2006/main" xmlns:r="http://schemas.openxmlformats.org/officeDocument/2006/relationships">
+  <p:cSld>
+    <p:bg>
+      <p:bgPr>
+        <a:solidFill>
+          <a:srgbClr val="002050"/>
+        </a:solidFill>
+        <a:effectLst/>
+      </p:bgPr>
+    </p:bg>
+    <p:spTree>
+      <p:nvGrpSpPr>
+        <p:cNvPr id="1" name=""/>
+        <p:cNvGrpSpPr/>
+        <p:nvPr/>
+      </p:nvGrpSpPr>
+      <p:grpSpPr/>
+      <p:sp>
+        <p:nvSpPr>
+          <p:cNvPr id="2" name="Rectangle 1"/>
+          <p:cNvSpPr/>
+          <p:nvPr/>
+        </p:nvSpPr>
+        <p:spPr>
+          <a:xfrm>
+            <a:off x="0" y="0"/>
+            <a:ext cx="12191695" cy="73152"/>
+          </a:xfrm>
+          <a:prstGeom prst="rect">
+            <a:avLst/>
+          </a:prstGeom>
+          <a:solidFill>
+            <a:srgbClr val="FFD700"/>
+          </a:solidFill>
+          <a:ln>
+            <a:noFill/>
+          </a:ln>
+        </p:spPr>
+        <p:style>
+          <a:lnRef idx="1">
+            <a:schemeClr val="accent1"/>
+          </a:lnRef>
+          <a:fillRef idx="3">
+            <a:schemeClr val="accent1"/>
+          </a:fillRef>
+          <a:effectRef idx="2">
+            <a:schemeClr val="accent1"/>
+          </a:effectRef>
+          <a:fontRef idx="minor">
+            <a:schemeClr val="lt1"/>
+          </a:fontRef>
+        </p:style>
+        <p:txBody>
+          <a:bodyPr rtlCol="0" anchor="ctr"/>
+          <a:lstStyle/>
+          <a:p>
+            <a:pPr algn="ctr"/>
+          </a:p>
+        </p:txBody>
+      </p:sp>
+      <p:sp>
+        <p:nvSpPr>
+          <p:cNvPr id="3" name="TextBox 2"/>
+          <p:cNvSpPr txBox="1"/>
+          <p:nvPr/>
+        </p:nvSpPr>
+        <p:spPr>
+          <a:xfrm>
+            <a:off x="914400" y="1828800"/>
+            <a:ext cx="10332720" cy="1371600"/>
+          </a:xfrm>
+          <a:prstGeom prst="rect">
+            <a:avLst/>
+          </a:prstGeom>
+          <a:noFill/>
+        </p:spPr>
+        <p:txBody>
+          <a:bodyPr wrap="square">
+            <a:spAutoFit/>
+          </a:bodyPr>
+          <a:lstStyle/>
+          <a:p>
+            <a:pPr algn="ctr">
+              <a:defRPr sz="5200" b="1">
+                <a:solidFill>
+                  <a:srgbClr val="FFFFFF"/>
+                </a:solidFill>
+                <a:latin typeface="Microsoft YaHei"/>
+              </a:defRPr>
+            </a:pPr>
+            <a:r>
+              <a:t>Thank You</a:t>
+            </a:r>
+          </a:p>
+        </p:txBody>
+      </p:sp>
+      <p:sp>
+        <p:nvSpPr>
+          <p:cNvPr id="4" name="TextBox 3"/>
+          <p:cNvSpPr txBox="1"/>
+          <p:nvPr/>
+        </p:nvSpPr>
+        <p:spPr>
+          <a:xfrm>
+            <a:off x="914400" y="3200400"/>
+            <a:ext cx="10332720" cy="731520"/>
+          </a:xfrm>
+          <a:prstGeom prst="rect">
+            <a:avLst/>
+          </a:prstGeom>
+          <a:noFill/>
+        </p:spPr>
+        <p:txBody>
+          <a:bodyPr wrap="square">
+            <a:spAutoFit/>
+          </a:bodyPr>
+          <a:lstStyle/>
+          <a:p>
+            <a:pPr algn="ctr">
+              <a:defRPr sz="3200" b="0">
+                <a:solidFill>
+                  <a:srgbClr val="FFD700"/>
+                </a:solidFill>
+                <a:latin typeface="Microsoft YaHei"/>
+              </a:defRPr>
+            </a:pPr>
+            <a:r>
+              <a:t>谢谢</a:t>
+            </a:r>
+          </a:p>
+        </p:txBody>
+      </p:sp>
+      <p:sp>
+        <p:nvSpPr>
+          <p:cNvPr id="5" name="Rectangle 4"/>
+          <p:cNvSpPr/>
+          <p:nvPr/>
+        </p:nvSpPr>
+        <p:spPr>
+          <a:xfrm>
+            <a:off x="4572000" y="4114800"/>
+            <a:ext cx="3017520" cy="36576"/>
+          </a:xfrm>
+          <a:prstGeom prst="rect">
+            <a:avLst/>
+          </a:prstGeom>
+          <a:solidFill>
+            <a:srgbClr val="FFD700"/>
+          </a:solidFill>
+          <a:ln>
+            <a:noFill/>
+          </a:ln>
+        </p:spPr>
+        <p:style>
+          <a:lnRef idx="1">
+            <a:schemeClr val="accent1"/>
+          </a:lnRef>
+          <a:fillRef idx="3">
+            <a:schemeClr val="accent1"/>
+          </a:fillRef>
+          <a:effectRef idx="2">
+            <a:schemeClr val="accent1"/>
+          </a:effectRef>
+          <a:fontRef idx="minor">
+            <a:schemeClr val="lt1"/>
+          </a:fontRef>
+        </p:style>
+        <p:txBody>
+          <a:bodyPr rtlCol="0" anchor="ctr"/>
+          <a:lstStyle/>
+          <a:p>
+            <a:pPr algn="ctr"/>
+          </a:p>
+        </p:txBody>
+      </p:sp>
+      <p:sp>
+        <p:nvSpPr>
+          <p:cNvPr id="6" name="TextBox 5"/>
+          <p:cNvSpPr txBox="1"/>
+          <p:nvPr/>
+        </p:nvSpPr>
+        <p:spPr>
+          <a:xfrm>
+            <a:off x="914400" y="4572000"/>
+            <a:ext cx="10332720" cy="1371600"/>
+          </a:xfrm>
+          <a:prstGeom prst="rect">
+            <a:avLst/>
+          </a:prstGeom>
+          <a:noFill/>
+        </p:spPr>
+        <p:txBody>
+          <a:bodyPr wrap="square">
+            <a:spAutoFit/>
+          </a:bodyPr>
+          <a:lstStyle/>
+          <a:p>
+            <a:pPr algn="ctr">
+              <a:spcAft>
+                <a:spcPts val="720"/>
+              </a:spcAft>
+              <a:defRPr sz="1800" b="0">
+                <a:solidFill>
+                  <a:srgbClr val="CCCCCC"/>
+                </a:solidFill>
+                <a:latin typeface="Microsoft YaHei"/>
+              </a:defRPr>
+            </a:pPr>
+            <a:r>
+              <a:t>Q &amp; A</a:t>
+            </a:r>
+          </a:p>
+          <a:p>
+            <a:pPr algn="ctr">
+              <a:spcAft>
+                <a:spcPts val="720"/>
+              </a:spcAft>
+              <a:defRPr sz="1800" b="0">
+                <a:solidFill>
+                  <a:srgbClr val="CCCCCC"/>
+                </a:solidFill>
+                <a:latin typeface="Microsoft YaHei"/>
+              </a:defRPr>
+            </a:pPr>
+          </a:p>
+          <a:p>
+            <a:pPr algn="ctr">
+              <a:spcAft>
+                <a:spcPts val="720"/>
+              </a:spcAft>
+              <a:defRPr sz="1800" b="0">
+                <a:solidFill>
+                  <a:srgbClr val="CCCCCC"/>
+                </a:solidFill>
+                <a:latin typeface="Microsoft YaHei"/>
+              </a:defRPr>
+            </a:pPr>
+            <a:r>
+              <a:t>汇报人：圆子  |  Senior Solution Engineer</a:t>
+            </a:r>
+          </a:p>
+          <a:p>
+            <a:pPr algn="ctr">
+              <a:spcAft>
+                <a:spcPts val="720"/>
+              </a:spcAft>
+              <a:defRPr sz="1800" b="0">
+                <a:solidFill>
+                  <a:srgbClr val="CCCCCC"/>
+                </a:solidFill>
+                <a:latin typeface="Microsoft YaHei"/>
+              </a:defRPr>
+            </a:pPr>
+            <a:r>
+              <a:t>Project 46 — Autonomous Retail Intelligence Agent Platform</a:t>
+            </a:r>
+          </a:p>
+        </p:txBody>
+      </p:sp>
+      <p:sp>
+        <p:nvSpPr>
+          <p:cNvPr id="7" name="Rectangle 6"/>
+          <p:cNvSpPr/>
+          <p:nvPr/>
+        </p:nvSpPr>
+        <p:spPr>
+          <a:xfrm>
+            <a:off x="0" y="6784848"/>
+            <a:ext cx="12191695" cy="73152"/>
+          </a:xfrm>
+          <a:prstGeom prst="rect">
+            <a:avLst/>
+          </a:prstGeom>
+          <a:solidFill>
+            <a:srgbClr val="FFD700"/>
+          </a:solidFill>
+          <a:ln>
+            <a:noFill/>
+          </a:ln>
+        </p:spPr>
+        <p:style>
+          <a:lnRef idx="1">
+            <a:schemeClr val="accent1"/>
+          </a:lnRef>
+          <a:fillRef idx="3">
+            <a:schemeClr val="accent1"/>
+          </a:fillRef>
+          <a:effectRef idx="2">
+            <a:schemeClr val="accent1"/>
+          </a:effectRef>
+          <a:fontRef idx="minor">
+            <a:schemeClr val="lt1"/>
+          </a:fontRef>
+        </p:style>
+        <p:txBody>
+          <a:bodyPr rtlCol="0" anchor="ctr"/>
+          <a:lstStyle/>
+          <a:p>
+            <a:pPr algn="ctr"/>
+          </a:p>
+        </p:txBody>
+      </p:sp>
+    </p:spTree>
+  </p:cSld>
+  <p:clrMapOvr>
+    <a:masterClrMapping/>
+  </p:clrMapOvr>
+</p:sld>
 </file>
 
 <file path=ppt/slides/slide3.xml><?xml version="1.0" encoding="utf-8"?>

</xml_diff>